<commit_message>
adicionando o Probabilistic AutoEncoder
</commit_message>
<xml_diff>
--- a/Atividade 3 - Identificação de Falhas/Apresentação 3 - FALTAS - Saulo.pptx
+++ b/Atividade 3 - Identificação de Falhas/Apresentação 3 - FALTAS - Saulo.pptx
@@ -5,7 +5,7 @@
     <p:sldMasterId id="2147483648" r:id="rId1"/>
   </p:sldMasterIdLst>
   <p:notesMasterIdLst>
-    <p:notesMasterId r:id="rId26"/>
+    <p:notesMasterId r:id="rId27"/>
   </p:notesMasterIdLst>
   <p:sldIdLst>
     <p:sldId id="257" r:id="rId2"/>
@@ -29,9 +29,10 @@
     <p:sldId id="399" r:id="rId20"/>
     <p:sldId id="403" r:id="rId21"/>
     <p:sldId id="409" r:id="rId22"/>
-    <p:sldId id="380" r:id="rId23"/>
-    <p:sldId id="408" r:id="rId24"/>
-    <p:sldId id="273" r:id="rId25"/>
+    <p:sldId id="412" r:id="rId23"/>
+    <p:sldId id="380" r:id="rId24"/>
+    <p:sldId id="408" r:id="rId25"/>
+    <p:sldId id="273" r:id="rId26"/>
   </p:sldIdLst>
   <p:sldSz cx="12192000" cy="6858000"/>
   <p:notesSz cx="6858000" cy="9144000"/>
@@ -9657,7 +9658,7 @@
         </p:blipFill>
         <p:spPr>
           <a:xfrm>
-            <a:off x="2002843" y="2347215"/>
+            <a:off x="1692693" y="2580514"/>
             <a:ext cx="4093157" cy="3105735"/>
           </a:xfrm>
           <a:prstGeom prst="rect">
@@ -9679,7 +9680,7 @@
         </p:nvSpPr>
         <p:spPr>
           <a:xfrm>
-            <a:off x="2002843" y="4715702"/>
+            <a:off x="1692693" y="4949001"/>
             <a:ext cx="3961330" cy="324465"/>
           </a:xfrm>
           <a:prstGeom prst="rect">
@@ -9730,7 +9731,7 @@
         </p:nvSpPr>
         <p:spPr>
           <a:xfrm>
-            <a:off x="2002843" y="2855564"/>
+            <a:off x="1692693" y="3028189"/>
             <a:ext cx="3961330" cy="324465"/>
           </a:xfrm>
           <a:prstGeom prst="rect">
@@ -9781,7 +9782,7 @@
         </p:nvSpPr>
         <p:spPr>
           <a:xfrm>
-            <a:off x="2002843" y="3908374"/>
+            <a:off x="1692693" y="4141673"/>
             <a:ext cx="3961330" cy="324465"/>
           </a:xfrm>
           <a:prstGeom prst="rect">
@@ -9832,8 +9833,8 @@
         </p:nvSpPr>
         <p:spPr>
           <a:xfrm>
-            <a:off x="6484387" y="2421800"/>
-            <a:ext cx="5117678" cy="384452"/>
+            <a:off x="6095999" y="2012358"/>
+            <a:ext cx="5389917" cy="3939284"/>
           </a:xfrm>
           <a:prstGeom prst="rect">
             <a:avLst/>
@@ -9853,54 +9854,40 @@
             </a:pPr>
             <a:r>
               <a:rPr lang="pt-BR" sz="1400" b="1" dirty="0"/>
-              <a:t>PAE (</a:t>
-            </a:r>
-            <a:r>
-              <a:rPr lang="pt-BR" sz="1400" b="1" dirty="0" err="1"/>
-              <a:t>Probabilistic</a:t>
-            </a:r>
+              <a:t>PAE:</a:t>
+            </a:r>
+          </a:p>
+          <a:p>
+            <a:pPr marL="800100" lvl="1" indent="-342900" algn="just">
+              <a:lnSpc>
+                <a:spcPct val="150000"/>
+              </a:lnSpc>
+              <a:buFont typeface="Wingdings" panose="05000000000000000000" pitchFamily="2" charset="2"/>
+              <a:buChar char="ü"/>
+            </a:pPr>
             <a:r>
               <a:rPr lang="pt-BR" sz="1400" b="1" dirty="0"/>
-              <a:t> Auto </a:t>
-            </a:r>
-            <a:r>
-              <a:rPr lang="pt-BR" sz="1400" b="1" dirty="0" err="1"/>
-              <a:t>Encoder</a:t>
-            </a:r>
-            <a:r>
-              <a:rPr lang="pt-BR" sz="1400" b="1" dirty="0"/>
-              <a:t>):  </a:t>
-            </a:r>
-          </a:p>
-        </p:txBody>
-      </p:sp>
-      <p:sp>
-        <p:nvSpPr>
-          <p:cNvPr id="17" name="CaixaDeTexto 16">
-            <a:extLst>
-              <a:ext uri="{FF2B5EF4-FFF2-40B4-BE49-F238E27FC236}">
-                <a16:creationId xmlns:a16="http://schemas.microsoft.com/office/drawing/2014/main" id="{EFB28A79-F3D9-17CF-22C9-62808211A21B}"/>
-              </a:ext>
-            </a:extLst>
-          </p:cNvPr>
-          <p:cNvSpPr txBox="1"/>
-          <p:nvPr/>
-        </p:nvSpPr>
-        <p:spPr>
-          <a:xfrm>
-            <a:off x="6484387" y="3533393"/>
-            <a:ext cx="5117678" cy="382165"/>
-          </a:xfrm>
-          <a:prstGeom prst="rect">
-            <a:avLst/>
-          </a:prstGeom>
-          <a:noFill/>
-        </p:spPr>
-        <p:txBody>
-          <a:bodyPr wrap="square">
-            <a:spAutoFit/>
-          </a:bodyPr>
-          <a:lstStyle/>
+              <a:t>MAIOR</a:t>
+            </a:r>
+            <a:r>
+              <a:rPr lang="pt-BR" sz="1400" dirty="0"/>
+              <a:t>  taxa de previsão (75,5%) (sensibilidade);</a:t>
+            </a:r>
+          </a:p>
+          <a:p>
+            <a:pPr marL="800100" lvl="1" indent="-342900" algn="just">
+              <a:lnSpc>
+                <a:spcPct val="150000"/>
+              </a:lnSpc>
+              <a:buFont typeface="Wingdings" panose="05000000000000000000" pitchFamily="2" charset="2"/>
+              <a:buChar char="ü"/>
+            </a:pPr>
+            <a:r>
+              <a:rPr lang="pt-BR" sz="1400" dirty="0"/>
+              <a:t>Gera muitos alarmes falsos;</a:t>
+            </a:r>
+            <a:endParaRPr lang="pt-BR" sz="1400" b="1" dirty="0"/>
+          </a:p>
           <a:p>
             <a:pPr algn="just">
               <a:lnSpc>
@@ -9909,38 +9896,36 @@
             </a:pPr>
             <a:r>
               <a:rPr lang="pt-BR" sz="1400" b="1" dirty="0"/>
-              <a:t>DPCA (Análise de Componentes Principais Dinâmica):  </a:t>
-            </a:r>
-          </a:p>
-        </p:txBody>
-      </p:sp>
-      <p:sp>
-        <p:nvSpPr>
-          <p:cNvPr id="19" name="CaixaDeTexto 18">
-            <a:extLst>
-              <a:ext uri="{FF2B5EF4-FFF2-40B4-BE49-F238E27FC236}">
-                <a16:creationId xmlns:a16="http://schemas.microsoft.com/office/drawing/2014/main" id="{8E6DE0ED-53B1-BB62-EE26-BA04E99E1721}"/>
-              </a:ext>
-            </a:extLst>
-          </p:cNvPr>
-          <p:cNvSpPr txBox="1"/>
-          <p:nvPr/>
-        </p:nvSpPr>
-        <p:spPr>
-          <a:xfrm>
-            <a:off x="6484387" y="4591740"/>
-            <a:ext cx="5117679" cy="384464"/>
-          </a:xfrm>
-          <a:prstGeom prst="rect">
-            <a:avLst/>
-          </a:prstGeom>
-          <a:noFill/>
-        </p:spPr>
-        <p:txBody>
-          <a:bodyPr wrap="square">
-            <a:spAutoFit/>
-          </a:bodyPr>
-          <a:lstStyle/>
+              <a:t>MPLS:</a:t>
+            </a:r>
+          </a:p>
+          <a:p>
+            <a:pPr marL="742950" lvl="1" indent="-285750" algn="just">
+              <a:lnSpc>
+                <a:spcPct val="150000"/>
+              </a:lnSpc>
+              <a:buFont typeface="Wingdings" panose="05000000000000000000" pitchFamily="2" charset="2"/>
+              <a:buChar char="ü"/>
+            </a:pPr>
+            <a:r>
+              <a:rPr lang="pt-BR" sz="1400" dirty="0"/>
+              <a:t>Alta taxa de previsão (~75%)</a:t>
+            </a:r>
+          </a:p>
+          <a:p>
+            <a:pPr marL="742950" lvl="1" indent="-285750" algn="just">
+              <a:lnSpc>
+                <a:spcPct val="150000"/>
+              </a:lnSpc>
+              <a:buFont typeface="Wingdings" panose="05000000000000000000" pitchFamily="2" charset="2"/>
+              <a:buChar char="ü"/>
+            </a:pPr>
+            <a:r>
+              <a:rPr lang="pt-BR" sz="1400" dirty="0"/>
+              <a:t>Foca principalmente em proteger a qualidade do produto;</a:t>
+            </a:r>
+            <a:endParaRPr lang="pt-BR" sz="1400" b="1" dirty="0"/>
+          </a:p>
           <a:p>
             <a:pPr algn="just">
               <a:lnSpc>
@@ -9949,46 +9934,36 @@
             </a:pPr>
             <a:r>
               <a:rPr lang="pt-BR" sz="1400" b="1" dirty="0"/>
-              <a:t>MICA (</a:t>
-            </a:r>
-            <a:r>
-              <a:rPr lang="pt-BR" sz="1400" b="1" dirty="0" err="1"/>
-              <a:t>Anáise</a:t>
-            </a:r>
-            <a:r>
-              <a:rPr lang="pt-BR" sz="1400" b="1" dirty="0"/>
-              <a:t> de Componentes Independentes Multivariada):  </a:t>
-            </a:r>
-          </a:p>
-        </p:txBody>
-      </p:sp>
-      <p:sp>
-        <p:nvSpPr>
-          <p:cNvPr id="20" name="CaixaDeTexto 19">
-            <a:extLst>
-              <a:ext uri="{FF2B5EF4-FFF2-40B4-BE49-F238E27FC236}">
-                <a16:creationId xmlns:a16="http://schemas.microsoft.com/office/drawing/2014/main" id="{31D8E454-3C2A-50E0-35AD-13C2F037A4EF}"/>
-              </a:ext>
-            </a:extLst>
-          </p:cNvPr>
-          <p:cNvSpPr txBox="1"/>
-          <p:nvPr/>
-        </p:nvSpPr>
-        <p:spPr>
-          <a:xfrm>
-            <a:off x="7086367" y="2845596"/>
-            <a:ext cx="3913718" cy="382165"/>
-          </a:xfrm>
-          <a:prstGeom prst="rect">
-            <a:avLst/>
-          </a:prstGeom>
-          <a:noFill/>
-        </p:spPr>
-        <p:txBody>
-          <a:bodyPr wrap="square">
-            <a:spAutoFit/>
-          </a:bodyPr>
-          <a:lstStyle/>
+              <a:t>DPCA:</a:t>
+            </a:r>
+          </a:p>
+          <a:p>
+            <a:pPr marL="742950" lvl="1" indent="-285750" algn="just">
+              <a:lnSpc>
+                <a:spcPct val="150000"/>
+              </a:lnSpc>
+              <a:buFont typeface="Wingdings" panose="05000000000000000000" pitchFamily="2" charset="2"/>
+              <a:buChar char="ü"/>
+            </a:pPr>
+            <a:r>
+              <a:rPr lang="pt-BR" sz="1400" dirty="0"/>
+              <a:t>Melhor Equilíbrio (FDR: 72,95% e FAR: 65,56%)</a:t>
+            </a:r>
+          </a:p>
+          <a:p>
+            <a:pPr marL="742950" lvl="1" indent="-285750" algn="just">
+              <a:lnSpc>
+                <a:spcPct val="150000"/>
+              </a:lnSpc>
+              <a:buFont typeface="Wingdings" panose="05000000000000000000" pitchFamily="2" charset="2"/>
+              <a:buChar char="ü"/>
+            </a:pPr>
+            <a:r>
+              <a:rPr lang="pt-BR" sz="1400" dirty="0"/>
+              <a:t>Permite filtrar ruídos rápidos e passageiros;</a:t>
+            </a:r>
+            <a:endParaRPr lang="pt-BR" sz="1400" b="1" dirty="0"/>
+          </a:p>
           <a:p>
             <a:pPr algn="just">
               <a:lnSpc>
@@ -9996,9 +9971,91 @@
               </a:lnSpc>
             </a:pPr>
             <a:r>
+              <a:rPr lang="pt-BR" sz="1400" b="1" dirty="0"/>
+              <a:t>MICA:</a:t>
+            </a:r>
+          </a:p>
+          <a:p>
+            <a:pPr marL="742950" lvl="1" indent="-285750" algn="just">
+              <a:lnSpc>
+                <a:spcPct val="150000"/>
+              </a:lnSpc>
+              <a:buFont typeface="Wingdings" panose="05000000000000000000" pitchFamily="2" charset="2"/>
+              <a:buChar char="ü"/>
+            </a:pPr>
+            <a:r>
               <a:rPr lang="pt-BR" sz="1400" dirty="0"/>
-              <a:t>Obteve a melhor FDR </a:t>
-            </a:r>
+              <a:t>Taxa de previsão considerável (64,5%)</a:t>
+            </a:r>
+          </a:p>
+          <a:p>
+            <a:pPr marL="742950" lvl="1" indent="-285750" algn="just">
+              <a:lnSpc>
+                <a:spcPct val="150000"/>
+              </a:lnSpc>
+              <a:buFont typeface="Wingdings" panose="05000000000000000000" pitchFamily="2" charset="2"/>
+              <a:buChar char="ü"/>
+            </a:pPr>
+            <a:r>
+              <a:rPr lang="pt-BR" sz="1400" b="1" dirty="0"/>
+              <a:t>MENOR</a:t>
+            </a:r>
+            <a:r>
+              <a:rPr lang="pt-BR" sz="1400" dirty="0"/>
+              <a:t> chance de gerar alarmes falsos (0,52%)</a:t>
+            </a:r>
+            <a:endParaRPr lang="pt-BR" sz="1400" b="1" dirty="0"/>
+          </a:p>
+        </p:txBody>
+      </p:sp>
+      <p:sp>
+        <p:nvSpPr>
+          <p:cNvPr id="21" name="Retângulo 20">
+            <a:extLst>
+              <a:ext uri="{FF2B5EF4-FFF2-40B4-BE49-F238E27FC236}">
+                <a16:creationId xmlns:a16="http://schemas.microsoft.com/office/drawing/2014/main" id="{A7CD3159-3352-2F27-C556-9AC9C2E6FC5B}"/>
+              </a:ext>
+            </a:extLst>
+          </p:cNvPr>
+          <p:cNvSpPr/>
+          <p:nvPr/>
+        </p:nvSpPr>
+        <p:spPr>
+          <a:xfrm>
+            <a:off x="1692693" y="3368245"/>
+            <a:ext cx="3961330" cy="324465"/>
+          </a:xfrm>
+          <a:prstGeom prst="rect">
+            <a:avLst/>
+          </a:prstGeom>
+          <a:solidFill>
+            <a:schemeClr val="accent2">
+              <a:alpha val="21961"/>
+            </a:schemeClr>
+          </a:solidFill>
+        </p:spPr>
+        <p:style>
+          <a:lnRef idx="2">
+            <a:schemeClr val="accent1">
+              <a:shade val="15000"/>
+            </a:schemeClr>
+          </a:lnRef>
+          <a:fillRef idx="1">
+            <a:schemeClr val="accent1"/>
+          </a:fillRef>
+          <a:effectRef idx="0">
+            <a:schemeClr val="accent1"/>
+          </a:effectRef>
+          <a:fontRef idx="minor">
+            <a:schemeClr val="lt1"/>
+          </a:fontRef>
+        </p:style>
+        <p:txBody>
+          <a:bodyPr rtlCol="0" anchor="ctr"/>
+          <a:lstStyle/>
+          <a:p>
+            <a:pPr algn="ctr"/>
+            <a:endParaRPr lang="pt-BR"/>
           </a:p>
         </p:txBody>
       </p:sp>
@@ -10179,6 +10236,59 @@
                       </p:childTnLst>
                     </p:cTn>
                   </p:par>
+                  <p:par>
+                    <p:cTn id="18" fill="hold">
+                      <p:stCondLst>
+                        <p:cond delay="indefinite"/>
+                      </p:stCondLst>
+                      <p:childTnLst>
+                        <p:par>
+                          <p:cTn id="19" fill="hold">
+                            <p:stCondLst>
+                              <p:cond delay="0"/>
+                            </p:stCondLst>
+                            <p:childTnLst>
+                              <p:par>
+                                <p:cTn id="20" presetID="10" presetClass="entr" presetSubtype="0" fill="hold" grpId="0" nodeType="clickEffect">
+                                  <p:stCondLst>
+                                    <p:cond delay="0"/>
+                                  </p:stCondLst>
+                                  <p:childTnLst>
+                                    <p:set>
+                                      <p:cBhvr>
+                                        <p:cTn id="21" dur="1" fill="hold">
+                                          <p:stCondLst>
+                                            <p:cond delay="0"/>
+                                          </p:stCondLst>
+                                        </p:cTn>
+                                        <p:tgtEl>
+                                          <p:spTgt spid="21"/>
+                                        </p:tgtEl>
+                                        <p:attrNameLst>
+                                          <p:attrName>style.visibility</p:attrName>
+                                        </p:attrNameLst>
+                                      </p:cBhvr>
+                                      <p:to>
+                                        <p:strVal val="visible"/>
+                                      </p:to>
+                                    </p:set>
+                                    <p:animEffect transition="in" filter="fade">
+                                      <p:cBhvr>
+                                        <p:cTn id="22" dur="500"/>
+                                        <p:tgtEl>
+                                          <p:spTgt spid="21"/>
+                                        </p:tgtEl>
+                                      </p:cBhvr>
+                                    </p:animEffect>
+                                  </p:childTnLst>
+                                </p:cTn>
+                              </p:par>
+                            </p:childTnLst>
+                          </p:cTn>
+                        </p:par>
+                      </p:childTnLst>
+                    </p:cTn>
+                  </p:par>
                 </p:childTnLst>
               </p:cTn>
               <p:prevCondLst>
@@ -10204,6 +10314,7 @@
       <p:bldP spid="9" grpId="0" animBg="1"/>
       <p:bldP spid="10" grpId="0" animBg="1"/>
       <p:bldP spid="11" grpId="0" animBg="1"/>
+      <p:bldP spid="21" grpId="0" animBg="1"/>
     </p:bldLst>
   </p:timing>
 </p:sld>
@@ -12780,7 +12891,7 @@
         <p:cNvPr id="1" name="">
           <a:extLst>
             <a:ext uri="{FF2B5EF4-FFF2-40B4-BE49-F238E27FC236}">
-              <a16:creationId xmlns:a16="http://schemas.microsoft.com/office/drawing/2014/main" id="{44AB1D3F-7EA7-0C8F-03E5-6DB5A4857FFE}"/>
+              <a16:creationId xmlns:a16="http://schemas.microsoft.com/office/drawing/2014/main" id="{1E6EA3BE-711C-A466-99A1-DEE03B2BC438}"/>
             </a:ext>
           </a:extLst>
         </p:cNvPr>
@@ -12800,7 +12911,7 @@
           <p:cNvPr id="6" name="Conector reto 5">
             <a:extLst>
               <a:ext uri="{FF2B5EF4-FFF2-40B4-BE49-F238E27FC236}">
-                <a16:creationId xmlns:a16="http://schemas.microsoft.com/office/drawing/2014/main" id="{6FB44E4F-9DC8-5ECE-3C69-5376241FB813}"/>
+                <a16:creationId xmlns:a16="http://schemas.microsoft.com/office/drawing/2014/main" id="{E8DAAD1E-43C5-2DCF-3C33-7F31A488DFAA}"/>
               </a:ext>
             </a:extLst>
           </p:cNvPr>
@@ -12839,7 +12950,7 @@
           <p:cNvPr id="12" name="CaixaDeTexto 11">
             <a:extLst>
               <a:ext uri="{FF2B5EF4-FFF2-40B4-BE49-F238E27FC236}">
-                <a16:creationId xmlns:a16="http://schemas.microsoft.com/office/drawing/2014/main" id="{49568142-3BC4-B698-C318-824E3078F81C}"/>
+                <a16:creationId xmlns:a16="http://schemas.microsoft.com/office/drawing/2014/main" id="{9B1CAE5A-EB15-E929-CA90-75E546C92369}"/>
               </a:ext>
             </a:extLst>
           </p:cNvPr>
@@ -12867,7 +12978,7 @@
                 <a:latin typeface="Arial" panose="020B0604020202020204" pitchFamily="34" charset="0"/>
                 <a:cs typeface="Arial" panose="020B0604020202020204" pitchFamily="34" charset="0"/>
               </a:rPr>
-              <a:t>REFERÊNCIAS</a:t>
+              <a:t>4. CONCLUSÕES</a:t>
             </a:r>
           </a:p>
           <a:p>
@@ -12883,7 +12994,7 @@
           <p:cNvPr id="5" name="CaixaDeTexto 4">
             <a:extLst>
               <a:ext uri="{FF2B5EF4-FFF2-40B4-BE49-F238E27FC236}">
-                <a16:creationId xmlns:a16="http://schemas.microsoft.com/office/drawing/2014/main" id="{D0C02250-31F5-7510-A3EB-017E92734BAC}"/>
+                <a16:creationId xmlns:a16="http://schemas.microsoft.com/office/drawing/2014/main" id="{B21BD1F8-86CE-E854-CB48-420F37FEF33A}"/>
               </a:ext>
             </a:extLst>
           </p:cNvPr>
@@ -12929,7 +13040,7 @@
           <p:cNvPr id="2" name="Título 1">
             <a:extLst>
               <a:ext uri="{FF2B5EF4-FFF2-40B4-BE49-F238E27FC236}">
-                <a16:creationId xmlns:a16="http://schemas.microsoft.com/office/drawing/2014/main" id="{4A12599A-9E1E-2F55-FE5C-F1006F37361B}"/>
+                <a16:creationId xmlns:a16="http://schemas.microsoft.com/office/drawing/2014/main" id="{0DCD174C-134D-8EC2-A781-E07D724F895F}"/>
               </a:ext>
             </a:extLst>
           </p:cNvPr>
@@ -13003,7 +13114,7 @@
           <p:cNvPr id="3" name="Picture 2" descr="Logomarcas">
             <a:extLst>
               <a:ext uri="{FF2B5EF4-FFF2-40B4-BE49-F238E27FC236}">
-                <a16:creationId xmlns:a16="http://schemas.microsoft.com/office/drawing/2014/main" id="{91301232-7129-EACB-B307-6D0B0D417815}"/>
+                <a16:creationId xmlns:a16="http://schemas.microsoft.com/office/drawing/2014/main" id="{DF0D47B1-83DE-D6BA-667A-F8048A202A17}"/>
               </a:ext>
             </a:extLst>
           </p:cNvPr>
@@ -13050,7 +13161,7 @@
           <p:cNvPr id="4" name="Rectangle 1">
             <a:extLst>
               <a:ext uri="{FF2B5EF4-FFF2-40B4-BE49-F238E27FC236}">
-                <a16:creationId xmlns:a16="http://schemas.microsoft.com/office/drawing/2014/main" id="{338FBFD4-D38B-272A-9F3F-3096A6872021}"/>
+                <a16:creationId xmlns:a16="http://schemas.microsoft.com/office/drawing/2014/main" id="{02B29862-EFFA-A472-CF2E-D9DCDF6E2313}"/>
               </a:ext>
             </a:extLst>
           </p:cNvPr>
@@ -13061,8 +13172,8 @@
         </p:nvSpPr>
         <p:spPr bwMode="auto">
           <a:xfrm>
-            <a:off x="1322094" y="2050161"/>
-            <a:ext cx="9547809" cy="2835648"/>
+            <a:off x="1223682" y="1382667"/>
+            <a:ext cx="4188754" cy="426207"/>
           </a:xfrm>
           <a:prstGeom prst="rect">
             <a:avLst/>
@@ -13110,7 +13221,62 @@
           </a:bodyPr>
           <a:lstStyle/>
           <a:p>
-            <a:pPr marL="228600" indent="-228600" algn="just">
+            <a:pPr eaLnBrk="0" fontAlgn="base" hangingPunct="0">
+              <a:lnSpc>
+                <a:spcPct val="150000"/>
+              </a:lnSpc>
+              <a:spcBef>
+                <a:spcPct val="0"/>
+              </a:spcBef>
+              <a:spcAft>
+                <a:spcPct val="0"/>
+              </a:spcAft>
+            </a:pPr>
+            <a:r>
+              <a:rPr lang="pt-BR" altLang="pt-BR" sz="1600" b="1" dirty="0">
+                <a:latin typeface="+mj-lt"/>
+              </a:rPr>
+              <a:t>TRABALHOS FUTUROS</a:t>
+            </a:r>
+            <a:endParaRPr kumimoji="0" lang="pt-BR" altLang="pt-BR" sz="1600" u="none" strike="noStrike" cap="none" normalizeH="0" baseline="0" dirty="0">
+              <a:ln>
+                <a:noFill/>
+              </a:ln>
+              <a:effectLst/>
+              <a:latin typeface="+mj-lt"/>
+            </a:endParaRPr>
+          </a:p>
+        </p:txBody>
+      </p:sp>
+      <p:sp>
+        <p:nvSpPr>
+          <p:cNvPr id="10" name="CaixaDeTexto 9">
+            <a:extLst>
+              <a:ext uri="{FF2B5EF4-FFF2-40B4-BE49-F238E27FC236}">
+                <a16:creationId xmlns:a16="http://schemas.microsoft.com/office/drawing/2014/main" id="{1D506863-B19F-0FE6-21E5-01C1DA95F01F}"/>
+              </a:ext>
+            </a:extLst>
+          </p:cNvPr>
+          <p:cNvSpPr txBox="1"/>
+          <p:nvPr/>
+        </p:nvSpPr>
+        <p:spPr>
+          <a:xfrm>
+            <a:off x="1317523" y="2050161"/>
+            <a:ext cx="6154994" cy="2545377"/>
+          </a:xfrm>
+          <a:prstGeom prst="rect">
+            <a:avLst/>
+          </a:prstGeom>
+          <a:noFill/>
+        </p:spPr>
+        <p:txBody>
+          <a:bodyPr wrap="square">
+            <a:spAutoFit/>
+          </a:bodyPr>
+          <a:lstStyle/>
+          <a:p>
+            <a:pPr marL="285750" indent="-285750">
               <a:lnSpc>
                 <a:spcPct val="150000"/>
               </a:lnSpc>
@@ -13118,52 +13284,12 @@
               <a:buChar char="•"/>
             </a:pPr>
             <a:r>
-              <a:rPr lang="pt-BR" sz="1200" dirty="0"/>
-              <a:t>DAYAL, B. S.; MACGREGOR, J. F. </a:t>
-            </a:r>
-            <a:r>
-              <a:rPr lang="pt-BR" sz="1200" dirty="0" err="1"/>
-              <a:t>Improved</a:t>
-            </a:r>
-            <a:r>
-              <a:rPr lang="pt-BR" sz="1200" dirty="0"/>
-              <a:t> PLS </a:t>
-            </a:r>
-            <a:r>
-              <a:rPr lang="pt-BR" sz="1200" dirty="0" err="1"/>
-              <a:t>algorithms</a:t>
-            </a:r>
-            <a:r>
-              <a:rPr lang="pt-BR" sz="1200" dirty="0"/>
-              <a:t>. </a:t>
-            </a:r>
-            <a:r>
-              <a:rPr lang="pt-BR" sz="1200" b="1" dirty="0" err="1"/>
-              <a:t>Journal</a:t>
-            </a:r>
-            <a:r>
-              <a:rPr lang="pt-BR" sz="1200" b="1" dirty="0"/>
-              <a:t> </a:t>
-            </a:r>
-            <a:r>
-              <a:rPr lang="pt-BR" sz="1200" b="1" dirty="0" err="1"/>
-              <a:t>of</a:t>
-            </a:r>
-            <a:r>
-              <a:rPr lang="pt-BR" sz="1200" b="1" dirty="0"/>
-              <a:t> </a:t>
-            </a:r>
-            <a:r>
-              <a:rPr lang="pt-BR" sz="1200" b="1" dirty="0" err="1"/>
-              <a:t>Chemometrics</a:t>
-            </a:r>
-            <a:r>
-              <a:rPr lang="pt-BR" sz="1200" dirty="0"/>
-              <a:t>, v. 11, n. 1, p. 73-85, 1997.</a:t>
-            </a:r>
-          </a:p>
-          <a:p>
-            <a:pPr marL="228600" indent="-228600" algn="just">
+              <a:rPr lang="pt-BR" dirty="0"/>
+              <a:t>Métodos híbridos e ensembles </a:t>
+            </a:r>
+          </a:p>
+          <a:p>
+            <a:pPr marL="285750" indent="-285750">
               <a:lnSpc>
                 <a:spcPct val="150000"/>
               </a:lnSpc>
@@ -13171,52 +13297,12 @@
               <a:buChar char="•"/>
             </a:pPr>
             <a:r>
-              <a:rPr lang="pt-BR" sz="1200" dirty="0"/>
-              <a:t>DOWNS, J. J.; VOGEL, E. F. A </a:t>
-            </a:r>
-            <a:r>
-              <a:rPr lang="pt-BR" sz="1200" dirty="0" err="1"/>
-              <a:t>plant-wide</a:t>
-            </a:r>
-            <a:r>
-              <a:rPr lang="pt-BR" sz="1200" dirty="0"/>
-              <a:t> industrial </a:t>
-            </a:r>
-            <a:r>
-              <a:rPr lang="pt-BR" sz="1200" dirty="0" err="1"/>
-              <a:t>process</a:t>
-            </a:r>
-            <a:r>
-              <a:rPr lang="pt-BR" sz="1200" dirty="0"/>
-              <a:t> </a:t>
-            </a:r>
-            <a:r>
-              <a:rPr lang="pt-BR" sz="1200" dirty="0" err="1"/>
-              <a:t>control</a:t>
-            </a:r>
-            <a:r>
-              <a:rPr lang="pt-BR" sz="1200" dirty="0"/>
-              <a:t> problem. </a:t>
-            </a:r>
-            <a:r>
-              <a:rPr lang="pt-BR" sz="1200" b="1" dirty="0" err="1"/>
-              <a:t>Computers</a:t>
-            </a:r>
-            <a:r>
-              <a:rPr lang="pt-BR" sz="1200" b="1" dirty="0"/>
-              <a:t> &amp; Chemical </a:t>
-            </a:r>
-            <a:r>
-              <a:rPr lang="pt-BR" sz="1200" b="1" dirty="0" err="1"/>
-              <a:t>Engineering</a:t>
-            </a:r>
-            <a:r>
-              <a:rPr lang="pt-BR" sz="1200" dirty="0"/>
-              <a:t>, v. 17, n. 3, p. 245–255, 1993.</a:t>
-            </a:r>
-          </a:p>
-          <a:p>
-            <a:pPr marL="228600" indent="-228600" algn="just">
+              <a:rPr lang="pt-BR" dirty="0"/>
+              <a:t>Abordagens de aprendizado profundo </a:t>
+            </a:r>
+          </a:p>
+          <a:p>
+            <a:pPr marL="285750" indent="-285750">
               <a:lnSpc>
                 <a:spcPct val="150000"/>
               </a:lnSpc>
@@ -13224,76 +13310,12 @@
               <a:buChar char="•"/>
             </a:pPr>
             <a:r>
-              <a:rPr lang="pt-BR" sz="1200" dirty="0"/>
-              <a:t>FAVOREEL, W.; DE MOOR, B.; VAN OVERSCHEE, P. </a:t>
-            </a:r>
-            <a:r>
-              <a:rPr lang="pt-BR" sz="1200" dirty="0" err="1"/>
-              <a:t>Subspace</a:t>
-            </a:r>
-            <a:r>
-              <a:rPr lang="pt-BR" sz="1200" dirty="0"/>
-              <a:t> </a:t>
-            </a:r>
-            <a:r>
-              <a:rPr lang="pt-BR" sz="1200" dirty="0" err="1"/>
-              <a:t>state</a:t>
-            </a:r>
-            <a:r>
-              <a:rPr lang="pt-BR" sz="1200" dirty="0"/>
-              <a:t> </a:t>
-            </a:r>
-            <a:r>
-              <a:rPr lang="pt-BR" sz="1200" dirty="0" err="1"/>
-              <a:t>space</a:t>
-            </a:r>
-            <a:r>
-              <a:rPr lang="pt-BR" sz="1200" dirty="0"/>
-              <a:t> system </a:t>
-            </a:r>
-            <a:r>
-              <a:rPr lang="pt-BR" sz="1200" dirty="0" err="1"/>
-              <a:t>identification</a:t>
-            </a:r>
-            <a:r>
-              <a:rPr lang="pt-BR" sz="1200" dirty="0"/>
-              <a:t> for industrial processes. </a:t>
-            </a:r>
-            <a:r>
-              <a:rPr lang="pt-BR" sz="1200" b="1" dirty="0" err="1"/>
-              <a:t>Journal</a:t>
-            </a:r>
-            <a:r>
-              <a:rPr lang="pt-BR" sz="1200" b="1" dirty="0"/>
-              <a:t> </a:t>
-            </a:r>
-            <a:r>
-              <a:rPr lang="pt-BR" sz="1200" b="1" dirty="0" err="1"/>
-              <a:t>of</a:t>
-            </a:r>
-            <a:r>
-              <a:rPr lang="pt-BR" sz="1200" b="1" dirty="0"/>
-              <a:t> </a:t>
-            </a:r>
-            <a:r>
-              <a:rPr lang="pt-BR" sz="1200" b="1" dirty="0" err="1"/>
-              <a:t>Process</a:t>
-            </a:r>
-            <a:r>
-              <a:rPr lang="pt-BR" sz="1200" b="1" dirty="0"/>
-              <a:t> </a:t>
-            </a:r>
-            <a:r>
-              <a:rPr lang="pt-BR" sz="1200" b="1" dirty="0" err="1"/>
-              <a:t>Control</a:t>
-            </a:r>
-            <a:r>
-              <a:rPr lang="pt-BR" sz="1200" dirty="0"/>
-              <a:t>, v. 10, n. 2-3, p. 149-155, 2000.</a:t>
-            </a:r>
-          </a:p>
-          <a:p>
-            <a:pPr marL="228600" indent="-228600" algn="just">
+              <a:rPr lang="pt-BR" dirty="0"/>
+              <a:t>Métodos de kernel </a:t>
+            </a:r>
+          </a:p>
+          <a:p>
+            <a:pPr marL="285750" indent="-285750">
               <a:lnSpc>
                 <a:spcPct val="150000"/>
               </a:lnSpc>
@@ -13301,88 +13323,12 @@
               <a:buChar char="•"/>
             </a:pPr>
             <a:r>
-              <a:rPr lang="pt-BR" sz="1200" dirty="0"/>
-              <a:t>GAVISH, M.; DONOHO, D. L. The </a:t>
-            </a:r>
-            <a:r>
-              <a:rPr lang="pt-BR" sz="1200" dirty="0" err="1"/>
-              <a:t>optimal</a:t>
-            </a:r>
-            <a:r>
-              <a:rPr lang="pt-BR" sz="1200" dirty="0"/>
-              <a:t> hard </a:t>
-            </a:r>
-            <a:r>
-              <a:rPr lang="pt-BR" sz="1200" dirty="0" err="1"/>
-              <a:t>threshold</a:t>
-            </a:r>
-            <a:r>
-              <a:rPr lang="pt-BR" sz="1200" dirty="0"/>
-              <a:t> for singular </a:t>
-            </a:r>
-            <a:r>
-              <a:rPr lang="pt-BR" sz="1200" dirty="0" err="1"/>
-              <a:t>values</a:t>
-            </a:r>
-            <a:r>
-              <a:rPr lang="pt-BR" sz="1200" dirty="0"/>
-              <a:t> </a:t>
-            </a:r>
-            <a:r>
-              <a:rPr lang="pt-BR" sz="1200" dirty="0" err="1"/>
-              <a:t>is</a:t>
-            </a:r>
-            <a:r>
-              <a:rPr lang="pt-BR" sz="1200" dirty="0"/>
-              <a:t> $4/\</a:t>
-            </a:r>
-            <a:r>
-              <a:rPr lang="pt-BR" sz="1200" dirty="0" err="1"/>
-              <a:t>sqrt</a:t>
-            </a:r>
-            <a:r>
-              <a:rPr lang="pt-BR" sz="1200" dirty="0"/>
-              <a:t>{3}$. </a:t>
-            </a:r>
-            <a:r>
-              <a:rPr lang="pt-BR" sz="1200" b="1" dirty="0"/>
-              <a:t>IEEE </a:t>
-            </a:r>
-            <a:r>
-              <a:rPr lang="pt-BR" sz="1200" b="1" dirty="0" err="1"/>
-              <a:t>Transactions</a:t>
-            </a:r>
-            <a:r>
-              <a:rPr lang="pt-BR" sz="1200" b="1" dirty="0"/>
-              <a:t> </a:t>
-            </a:r>
-            <a:r>
-              <a:rPr lang="pt-BR" sz="1200" b="1" dirty="0" err="1"/>
-              <a:t>on</a:t>
-            </a:r>
-            <a:r>
-              <a:rPr lang="pt-BR" sz="1200" b="1" dirty="0"/>
-              <a:t> </a:t>
-            </a:r>
-            <a:r>
-              <a:rPr lang="pt-BR" sz="1200" b="1" dirty="0" err="1"/>
-              <a:t>Information</a:t>
-            </a:r>
-            <a:r>
-              <a:rPr lang="pt-BR" sz="1200" b="1" dirty="0"/>
-              <a:t> </a:t>
-            </a:r>
-            <a:r>
-              <a:rPr lang="pt-BR" sz="1200" b="1" dirty="0" err="1"/>
-              <a:t>Theory</a:t>
-            </a:r>
-            <a:r>
-              <a:rPr lang="pt-BR" sz="1200" dirty="0"/>
-              <a:t>, v. 60, n. 8, p. 5040-5053, 2014.</a:t>
-            </a:r>
-          </a:p>
-          <a:p>
-            <a:pPr marL="228600" indent="-228600" algn="just">
+              <a:rPr lang="pt-BR" dirty="0"/>
+              <a:t>Aprendizado por transferência </a:t>
+            </a:r>
+          </a:p>
+          <a:p>
+            <a:pPr marL="285750" indent="-285750">
               <a:lnSpc>
                 <a:spcPct val="150000"/>
               </a:lnSpc>
@@ -13390,28 +13336,21 @@
               <a:buChar char="•"/>
             </a:pPr>
             <a:r>
-              <a:rPr lang="pt-BR" sz="1200" dirty="0"/>
-              <a:t>GERMANO, A. </a:t>
-            </a:r>
-            <a:r>
-              <a:rPr lang="pt-BR" sz="1200" i="1" dirty="0"/>
-              <a:t>et al</a:t>
-            </a:r>
-            <a:r>
-              <a:rPr lang="pt-BR" sz="1200" dirty="0"/>
-              <a:t>. Detecção de falhas no processo Tennessee Eastman utilizando métricas de tipicidade e excentricidade. In: INTERNATIONAL CONFERENCE ON CONTROL, AUTOMATION AND SYSTEMS (ICCAS), 13., 2016. </a:t>
-            </a:r>
-            <a:r>
-              <a:rPr lang="pt-BR" sz="1200" b="1" dirty="0" err="1"/>
-              <a:t>Proceedings</a:t>
-            </a:r>
-            <a:r>
-              <a:rPr lang="pt-BR" sz="1200" b="1" dirty="0"/>
-              <a:t> [...]</a:t>
-            </a:r>
-            <a:r>
-              <a:rPr lang="pt-BR" sz="1200" dirty="0"/>
-              <a:t>. [S. l.: s. n.], 2016. p. 1000–1005.</a:t>
+              <a:rPr lang="pt-BR" dirty="0"/>
+              <a:t>Implementação em tempo real </a:t>
+            </a:r>
+          </a:p>
+          <a:p>
+            <a:pPr marL="285750" indent="-285750">
+              <a:lnSpc>
+                <a:spcPct val="150000"/>
+              </a:lnSpc>
+              <a:buFont typeface="Arial" panose="020B0604020202020204" pitchFamily="34" charset="0"/>
+              <a:buChar char="•"/>
+            </a:pPr>
+            <a:r>
+              <a:rPr lang="pt-BR" dirty="0"/>
+              <a:t>Análise de causa raiz </a:t>
             </a:r>
           </a:p>
         </p:txBody>
@@ -13419,7 +13358,7 @@
     </p:spTree>
     <p:extLst>
       <p:ext uri="{BB962C8B-B14F-4D97-AF65-F5344CB8AC3E}">
-        <p14:creationId xmlns:p14="http://schemas.microsoft.com/office/powerpoint/2010/main" val="3487896579"/>
+        <p14:creationId xmlns:p14="http://schemas.microsoft.com/office/powerpoint/2010/main" val="1035706997"/>
       </p:ext>
     </p:extLst>
   </p:cSld>
@@ -13437,7 +13376,7 @@
         <p:cNvPr id="1" name="">
           <a:extLst>
             <a:ext uri="{FF2B5EF4-FFF2-40B4-BE49-F238E27FC236}">
-              <a16:creationId xmlns:a16="http://schemas.microsoft.com/office/drawing/2014/main" id="{75363010-CED7-4F51-C583-4CE57DFDC27C}"/>
+              <a16:creationId xmlns:a16="http://schemas.microsoft.com/office/drawing/2014/main" id="{44AB1D3F-7EA7-0C8F-03E5-6DB5A4857FFE}"/>
             </a:ext>
           </a:extLst>
         </p:cNvPr>
@@ -13457,7 +13396,7 @@
           <p:cNvPr id="6" name="Conector reto 5">
             <a:extLst>
               <a:ext uri="{FF2B5EF4-FFF2-40B4-BE49-F238E27FC236}">
-                <a16:creationId xmlns:a16="http://schemas.microsoft.com/office/drawing/2014/main" id="{62B55BD1-485B-E5AC-BC2C-F7B1B2E4016D}"/>
+                <a16:creationId xmlns:a16="http://schemas.microsoft.com/office/drawing/2014/main" id="{6FB44E4F-9DC8-5ECE-3C69-5376241FB813}"/>
               </a:ext>
             </a:extLst>
           </p:cNvPr>
@@ -13496,7 +13435,7 @@
           <p:cNvPr id="12" name="CaixaDeTexto 11">
             <a:extLst>
               <a:ext uri="{FF2B5EF4-FFF2-40B4-BE49-F238E27FC236}">
-                <a16:creationId xmlns:a16="http://schemas.microsoft.com/office/drawing/2014/main" id="{8596AFB1-8ED6-4AFE-B90E-32145A1CF7B9}"/>
+                <a16:creationId xmlns:a16="http://schemas.microsoft.com/office/drawing/2014/main" id="{49568142-3BC4-B698-C318-824E3078F81C}"/>
               </a:ext>
             </a:extLst>
           </p:cNvPr>
@@ -13540,7 +13479,7 @@
           <p:cNvPr id="5" name="CaixaDeTexto 4">
             <a:extLst>
               <a:ext uri="{FF2B5EF4-FFF2-40B4-BE49-F238E27FC236}">
-                <a16:creationId xmlns:a16="http://schemas.microsoft.com/office/drawing/2014/main" id="{526958D8-33AE-4391-289C-018DF30C2D20}"/>
+                <a16:creationId xmlns:a16="http://schemas.microsoft.com/office/drawing/2014/main" id="{D0C02250-31F5-7510-A3EB-017E92734BAC}"/>
               </a:ext>
             </a:extLst>
           </p:cNvPr>
@@ -13586,7 +13525,7 @@
           <p:cNvPr id="2" name="Título 1">
             <a:extLst>
               <a:ext uri="{FF2B5EF4-FFF2-40B4-BE49-F238E27FC236}">
-                <a16:creationId xmlns:a16="http://schemas.microsoft.com/office/drawing/2014/main" id="{5496B41D-4DC0-1668-3102-606087DDEAF7}"/>
+                <a16:creationId xmlns:a16="http://schemas.microsoft.com/office/drawing/2014/main" id="{4A12599A-9E1E-2F55-FE5C-F1006F37361B}"/>
               </a:ext>
             </a:extLst>
           </p:cNvPr>
@@ -13660,7 +13599,7 @@
           <p:cNvPr id="3" name="Picture 2" descr="Logomarcas">
             <a:extLst>
               <a:ext uri="{FF2B5EF4-FFF2-40B4-BE49-F238E27FC236}">
-                <a16:creationId xmlns:a16="http://schemas.microsoft.com/office/drawing/2014/main" id="{1B3CA2A4-0073-1125-0ABE-D7079E5B965B}"/>
+                <a16:creationId xmlns:a16="http://schemas.microsoft.com/office/drawing/2014/main" id="{91301232-7129-EACB-B307-6D0B0D417815}"/>
               </a:ext>
             </a:extLst>
           </p:cNvPr>
@@ -13707,7 +13646,7 @@
           <p:cNvPr id="4" name="Rectangle 1">
             <a:extLst>
               <a:ext uri="{FF2B5EF4-FFF2-40B4-BE49-F238E27FC236}">
-                <a16:creationId xmlns:a16="http://schemas.microsoft.com/office/drawing/2014/main" id="{BAF476CD-2D37-141B-53C7-60DB2186AA6A}"/>
+                <a16:creationId xmlns:a16="http://schemas.microsoft.com/office/drawing/2014/main" id="{338FBFD4-D38B-272A-9F3F-3096A6872021}"/>
               </a:ext>
             </a:extLst>
           </p:cNvPr>
@@ -13718,8 +13657,8 @@
         </p:nvSpPr>
         <p:spPr bwMode="auto">
           <a:xfrm>
-            <a:off x="1322094" y="1960502"/>
-            <a:ext cx="9547809" cy="3666645"/>
+            <a:off x="1322094" y="2050161"/>
+            <a:ext cx="9547809" cy="2835648"/>
           </a:xfrm>
           <a:prstGeom prst="rect">
             <a:avLst/>
@@ -13776,15 +13715,27 @@
             </a:pPr>
             <a:r>
               <a:rPr lang="pt-BR" sz="1200" dirty="0"/>
-              <a:t>GERON, A. </a:t>
-            </a:r>
-            <a:r>
-              <a:rPr lang="pt-BR" sz="1200" b="1" dirty="0"/>
-              <a:t>Hands-On Machine Learning </a:t>
+              <a:t>DAYAL, B. S.; MACGREGOR, J. F. </a:t>
+            </a:r>
+            <a:r>
+              <a:rPr lang="pt-BR" sz="1200" dirty="0" err="1"/>
+              <a:t>Improved</a:t>
+            </a:r>
+            <a:r>
+              <a:rPr lang="pt-BR" sz="1200" dirty="0"/>
+              <a:t> PLS </a:t>
+            </a:r>
+            <a:r>
+              <a:rPr lang="pt-BR" sz="1200" dirty="0" err="1"/>
+              <a:t>algorithms</a:t>
+            </a:r>
+            <a:r>
+              <a:rPr lang="pt-BR" sz="1200" dirty="0"/>
+              <a:t>. </a:t>
             </a:r>
             <a:r>
               <a:rPr lang="pt-BR" sz="1200" b="1" dirty="0" err="1"/>
-              <a:t>with</a:t>
+              <a:t>Journal</a:t>
             </a:r>
             <a:r>
               <a:rPr lang="pt-BR" sz="1200" b="1" dirty="0"/>
@@ -13792,23 +13743,7 @@
             </a:r>
             <a:r>
               <a:rPr lang="pt-BR" sz="1200" b="1" dirty="0" err="1"/>
-              <a:t>Scikit-Learn</a:t>
-            </a:r>
-            <a:r>
-              <a:rPr lang="pt-BR" sz="1200" b="1" dirty="0"/>
-              <a:t>, </a:t>
-            </a:r>
-            <a:r>
-              <a:rPr lang="pt-BR" sz="1200" b="1" dirty="0" err="1"/>
-              <a:t>Keras</a:t>
-            </a:r>
-            <a:r>
-              <a:rPr lang="pt-BR" sz="1200" b="1" dirty="0"/>
-              <a:t>, </a:t>
-            </a:r>
-            <a:r>
-              <a:rPr lang="pt-BR" sz="1200" b="1" dirty="0" err="1"/>
-              <a:t>and</a:t>
+              <a:t>of</a:t>
             </a:r>
             <a:r>
               <a:rPr lang="pt-BR" sz="1200" b="1" dirty="0"/>
@@ -13816,51 +13751,11 @@
             </a:r>
             <a:r>
               <a:rPr lang="pt-BR" sz="1200" b="1" dirty="0" err="1"/>
-              <a:t>TensorFlow</a:t>
+              <a:t>Chemometrics</a:t>
             </a:r>
             <a:r>
               <a:rPr lang="pt-BR" sz="1200" dirty="0"/>
-              <a:t>: </a:t>
-            </a:r>
-            <a:r>
-              <a:rPr lang="pt-BR" sz="1200" dirty="0" err="1"/>
-              <a:t>Concepts</a:t>
-            </a:r>
-            <a:r>
-              <a:rPr lang="pt-BR" sz="1200" dirty="0"/>
-              <a:t>, Tools, </a:t>
-            </a:r>
-            <a:r>
-              <a:rPr lang="pt-BR" sz="1200" dirty="0" err="1"/>
-              <a:t>and</a:t>
-            </a:r>
-            <a:r>
-              <a:rPr lang="pt-BR" sz="1200" dirty="0"/>
-              <a:t> </a:t>
-            </a:r>
-            <a:r>
-              <a:rPr lang="pt-BR" sz="1200" dirty="0" err="1"/>
-              <a:t>Techniques</a:t>
-            </a:r>
-            <a:r>
-              <a:rPr lang="pt-BR" sz="1200" dirty="0"/>
-              <a:t> </a:t>
-            </a:r>
-            <a:r>
-              <a:rPr lang="pt-BR" sz="1200" dirty="0" err="1"/>
-              <a:t>to</a:t>
-            </a:r>
-            <a:r>
-              <a:rPr lang="pt-BR" sz="1200" dirty="0"/>
-              <a:t> Build </a:t>
-            </a:r>
-            <a:r>
-              <a:rPr lang="pt-BR" sz="1200" dirty="0" err="1"/>
-              <a:t>Intelligent</a:t>
-            </a:r>
-            <a:r>
-              <a:rPr lang="pt-BR" sz="1200" dirty="0"/>
-              <a:t> Systems. 2. ed. [S. l.]: O’Reilly Media, Inc., 2019.</a:t>
+              <a:t>, v. 11, n. 1, p. 73-85, 1997.</a:t>
             </a:r>
           </a:p>
           <a:p>
@@ -13873,51 +13768,47 @@
             </a:pPr>
             <a:r>
               <a:rPr lang="pt-BR" sz="1200" dirty="0"/>
-              <a:t>GERTLER, J. </a:t>
+              <a:t>DOWNS, J. J.; VOGEL, E. F. A </a:t>
+            </a:r>
+            <a:r>
+              <a:rPr lang="pt-BR" sz="1200" dirty="0" err="1"/>
+              <a:t>plant-wide</a:t>
+            </a:r>
+            <a:r>
+              <a:rPr lang="pt-BR" sz="1200" dirty="0"/>
+              <a:t> industrial </a:t>
+            </a:r>
+            <a:r>
+              <a:rPr lang="pt-BR" sz="1200" dirty="0" err="1"/>
+              <a:t>process</a:t>
+            </a:r>
+            <a:r>
+              <a:rPr lang="pt-BR" sz="1200" dirty="0"/>
+              <a:t> </a:t>
+            </a:r>
+            <a:r>
+              <a:rPr lang="pt-BR" sz="1200" dirty="0" err="1"/>
+              <a:t>control</a:t>
+            </a:r>
+            <a:r>
+              <a:rPr lang="pt-BR" sz="1200" dirty="0"/>
+              <a:t> problem. </a:t>
             </a:r>
             <a:r>
               <a:rPr lang="pt-BR" sz="1200" b="1" dirty="0" err="1"/>
-              <a:t>Fault</a:t>
+              <a:t>Computers</a:t>
             </a:r>
             <a:r>
               <a:rPr lang="pt-BR" sz="1200" b="1" dirty="0"/>
-              <a:t> </a:t>
+              <a:t> &amp; Chemical </a:t>
             </a:r>
             <a:r>
               <a:rPr lang="pt-BR" sz="1200" b="1" dirty="0" err="1"/>
-              <a:t>detection</a:t>
-            </a:r>
-            <a:r>
-              <a:rPr lang="pt-BR" sz="1200" b="1" dirty="0"/>
-              <a:t> </a:t>
-            </a:r>
-            <a:r>
-              <a:rPr lang="pt-BR" sz="1200" b="1" dirty="0" err="1"/>
-              <a:t>and</a:t>
-            </a:r>
-            <a:r>
-              <a:rPr lang="pt-BR" sz="1200" b="1" dirty="0"/>
-              <a:t> </a:t>
-            </a:r>
-            <a:r>
-              <a:rPr lang="pt-BR" sz="1200" b="1" dirty="0" err="1"/>
-              <a:t>diagnosis</a:t>
-            </a:r>
-            <a:r>
-              <a:rPr lang="pt-BR" sz="1200" b="1" dirty="0"/>
-              <a:t> in </a:t>
-            </a:r>
-            <a:r>
-              <a:rPr lang="pt-BR" sz="1200" b="1" dirty="0" err="1"/>
-              <a:t>engineering</a:t>
-            </a:r>
-            <a:r>
-              <a:rPr lang="pt-BR" sz="1200" b="1" dirty="0"/>
-              <a:t> systems</a:t>
+              <a:t>Engineering</a:t>
             </a:r>
             <a:r>
               <a:rPr lang="pt-BR" sz="1200" dirty="0"/>
-              <a:t>. New York: Marcel Dekker, 1998.</a:t>
+              <a:t>, v. 17, n. 3, p. 245–255, 1993.</a:t>
             </a:r>
           </a:p>
           <a:p>
@@ -13930,11 +13821,43 @@
             </a:pPr>
             <a:r>
               <a:rPr lang="pt-BR" sz="1200" dirty="0"/>
-              <a:t>ISERMANN, R. </a:t>
+              <a:t>FAVOREEL, W.; DE MOOR, B.; VAN OVERSCHEE, P. </a:t>
+            </a:r>
+            <a:r>
+              <a:rPr lang="pt-BR" sz="1200" dirty="0" err="1"/>
+              <a:t>Subspace</a:t>
+            </a:r>
+            <a:r>
+              <a:rPr lang="pt-BR" sz="1200" dirty="0"/>
+              <a:t> </a:t>
+            </a:r>
+            <a:r>
+              <a:rPr lang="pt-BR" sz="1200" dirty="0" err="1"/>
+              <a:t>state</a:t>
+            </a:r>
+            <a:r>
+              <a:rPr lang="pt-BR" sz="1200" dirty="0"/>
+              <a:t> </a:t>
+            </a:r>
+            <a:r>
+              <a:rPr lang="pt-BR" sz="1200" dirty="0" err="1"/>
+              <a:t>space</a:t>
+            </a:r>
+            <a:r>
+              <a:rPr lang="pt-BR" sz="1200" dirty="0"/>
+              <a:t> system </a:t>
+            </a:r>
+            <a:r>
+              <a:rPr lang="pt-BR" sz="1200" dirty="0" err="1"/>
+              <a:t>identification</a:t>
+            </a:r>
+            <a:r>
+              <a:rPr lang="pt-BR" sz="1200" dirty="0"/>
+              <a:t> for industrial processes. </a:t>
             </a:r>
             <a:r>
               <a:rPr lang="pt-BR" sz="1200" b="1" dirty="0" err="1"/>
-              <a:t>Fault-diagnosis</a:t>
+              <a:t>Journal</a:t>
             </a:r>
             <a:r>
               <a:rPr lang="pt-BR" sz="1200" b="1" dirty="0"/>
@@ -13942,59 +13865,27 @@
             </a:r>
             <a:r>
               <a:rPr lang="pt-BR" sz="1200" b="1" dirty="0" err="1"/>
-              <a:t>applications</a:t>
+              <a:t>of</a:t>
+            </a:r>
+            <a:r>
+              <a:rPr lang="pt-BR" sz="1200" b="1" dirty="0"/>
+              <a:t> </a:t>
+            </a:r>
+            <a:r>
+              <a:rPr lang="pt-BR" sz="1200" b="1" dirty="0" err="1"/>
+              <a:t>Process</a:t>
+            </a:r>
+            <a:r>
+              <a:rPr lang="pt-BR" sz="1200" b="1" dirty="0"/>
+              <a:t> </a:t>
+            </a:r>
+            <a:r>
+              <a:rPr lang="pt-BR" sz="1200" b="1" dirty="0" err="1"/>
+              <a:t>Control</a:t>
             </a:r>
             <a:r>
               <a:rPr lang="pt-BR" sz="1200" dirty="0"/>
-              <a:t>: Model-</a:t>
-            </a:r>
-            <a:r>
-              <a:rPr lang="pt-BR" sz="1200" dirty="0" err="1"/>
-              <a:t>aided</a:t>
-            </a:r>
-            <a:r>
-              <a:rPr lang="pt-BR" sz="1200" dirty="0"/>
-              <a:t> </a:t>
-            </a:r>
-            <a:r>
-              <a:rPr lang="pt-BR" sz="1200" dirty="0" err="1"/>
-              <a:t>diagnosis</a:t>
-            </a:r>
-            <a:r>
-              <a:rPr lang="pt-BR" sz="1200" dirty="0"/>
-              <a:t> </a:t>
-            </a:r>
-            <a:r>
-              <a:rPr lang="pt-BR" sz="1200" dirty="0" err="1"/>
-              <a:t>and</a:t>
-            </a:r>
-            <a:r>
-              <a:rPr lang="pt-BR" sz="1200" dirty="0"/>
-              <a:t> </a:t>
-            </a:r>
-            <a:r>
-              <a:rPr lang="pt-BR" sz="1200" dirty="0" err="1"/>
-              <a:t>fault-tolerant</a:t>
-            </a:r>
-            <a:r>
-              <a:rPr lang="pt-BR" sz="1200" dirty="0"/>
-              <a:t> </a:t>
-            </a:r>
-            <a:r>
-              <a:rPr lang="pt-BR" sz="1200" dirty="0" err="1"/>
-              <a:t>control</a:t>
-            </a:r>
-            <a:r>
-              <a:rPr lang="pt-BR" sz="1200" dirty="0"/>
-              <a:t>. Berlin, Heidelberg: Springer-</a:t>
-            </a:r>
-            <a:r>
-              <a:rPr lang="pt-BR" sz="1200" dirty="0" err="1"/>
-              <a:t>Verlag</a:t>
-            </a:r>
-            <a:r>
-              <a:rPr lang="pt-BR" sz="1200" dirty="0"/>
-              <a:t>, 2011.</a:t>
+              <a:t>, v. 10, n. 2-3, p. 149-155, 2000.</a:t>
             </a:r>
           </a:p>
           <a:p>
@@ -14007,60 +13898,802 @@
             </a:pPr>
             <a:r>
               <a:rPr lang="pt-BR" sz="1200" dirty="0"/>
+              <a:t>GAVISH, M.; DONOHO, D. L. The </a:t>
+            </a:r>
+            <a:r>
+              <a:rPr lang="pt-BR" sz="1200" dirty="0" err="1"/>
+              <a:t>optimal</a:t>
+            </a:r>
+            <a:r>
+              <a:rPr lang="pt-BR" sz="1200" dirty="0"/>
+              <a:t> hard </a:t>
+            </a:r>
+            <a:r>
+              <a:rPr lang="pt-BR" sz="1200" dirty="0" err="1"/>
+              <a:t>threshold</a:t>
+            </a:r>
+            <a:r>
+              <a:rPr lang="pt-BR" sz="1200" dirty="0"/>
+              <a:t> for singular </a:t>
+            </a:r>
+            <a:r>
+              <a:rPr lang="pt-BR" sz="1200" dirty="0" err="1"/>
+              <a:t>values</a:t>
+            </a:r>
+            <a:r>
+              <a:rPr lang="pt-BR" sz="1200" dirty="0"/>
+              <a:t> </a:t>
+            </a:r>
+            <a:r>
+              <a:rPr lang="pt-BR" sz="1200" dirty="0" err="1"/>
+              <a:t>is</a:t>
+            </a:r>
+            <a:r>
+              <a:rPr lang="pt-BR" sz="1200" dirty="0"/>
+              <a:t> $4/\</a:t>
+            </a:r>
+            <a:r>
+              <a:rPr lang="pt-BR" sz="1200" dirty="0" err="1"/>
+              <a:t>sqrt</a:t>
+            </a:r>
+            <a:r>
+              <a:rPr lang="pt-BR" sz="1200" dirty="0"/>
+              <a:t>{3}$. </a:t>
+            </a:r>
+            <a:r>
+              <a:rPr lang="pt-BR" sz="1200" b="1" dirty="0"/>
+              <a:t>IEEE </a:t>
+            </a:r>
+            <a:r>
+              <a:rPr lang="pt-BR" sz="1200" b="1" dirty="0" err="1"/>
+              <a:t>Transactions</a:t>
+            </a:r>
+            <a:r>
+              <a:rPr lang="pt-BR" sz="1200" b="1" dirty="0"/>
+              <a:t> </a:t>
+            </a:r>
+            <a:r>
+              <a:rPr lang="pt-BR" sz="1200" b="1" dirty="0" err="1"/>
+              <a:t>on</a:t>
+            </a:r>
+            <a:r>
+              <a:rPr lang="pt-BR" sz="1200" b="1" dirty="0"/>
+              <a:t> </a:t>
+            </a:r>
+            <a:r>
+              <a:rPr lang="pt-BR" sz="1200" b="1" dirty="0" err="1"/>
+              <a:t>Information</a:t>
+            </a:r>
+            <a:r>
+              <a:rPr lang="pt-BR" sz="1200" b="1" dirty="0"/>
+              <a:t> </a:t>
+            </a:r>
+            <a:r>
+              <a:rPr lang="pt-BR" sz="1200" b="1" dirty="0" err="1"/>
+              <a:t>Theory</a:t>
+            </a:r>
+            <a:r>
+              <a:rPr lang="pt-BR" sz="1200" dirty="0"/>
+              <a:t>, v. 60, n. 8, p. 5040-5053, 2014.</a:t>
+            </a:r>
+          </a:p>
+          <a:p>
+            <a:pPr marL="228600" indent="-228600" algn="just">
+              <a:lnSpc>
+                <a:spcPct val="150000"/>
+              </a:lnSpc>
+              <a:buFont typeface="Arial" panose="020B0604020202020204" pitchFamily="34" charset="0"/>
+              <a:buChar char="•"/>
+            </a:pPr>
+            <a:r>
+              <a:rPr lang="pt-BR" sz="1200" dirty="0"/>
+              <a:t>GERMANO, A. </a:t>
+            </a:r>
+            <a:r>
+              <a:rPr lang="pt-BR" sz="1200" i="1" dirty="0"/>
+              <a:t>et al</a:t>
+            </a:r>
+            <a:r>
+              <a:rPr lang="pt-BR" sz="1200" dirty="0"/>
+              <a:t>. Detecção de falhas no processo Tennessee Eastman utilizando métricas de tipicidade e excentricidade. In: INTERNATIONAL CONFERENCE ON CONTROL, AUTOMATION AND SYSTEMS (ICCAS), 13., 2016. </a:t>
+            </a:r>
+            <a:r>
+              <a:rPr lang="pt-BR" sz="1200" b="1" dirty="0" err="1"/>
+              <a:t>Proceedings</a:t>
+            </a:r>
+            <a:r>
+              <a:rPr lang="pt-BR" sz="1200" b="1" dirty="0"/>
+              <a:t> [...]</a:t>
+            </a:r>
+            <a:r>
+              <a:rPr lang="pt-BR" sz="1200" dirty="0"/>
+              <a:t>. [S. l.: s. n.], 2016. p. 1000–1005.</a:t>
+            </a:r>
+          </a:p>
+        </p:txBody>
+      </p:sp>
+    </p:spTree>
+    <p:extLst>
+      <p:ext uri="{BB962C8B-B14F-4D97-AF65-F5344CB8AC3E}">
+        <p14:creationId xmlns:p14="http://schemas.microsoft.com/office/powerpoint/2010/main" val="3487896579"/>
+      </p:ext>
+    </p:extLst>
+  </p:cSld>
+  <p:clrMapOvr>
+    <a:masterClrMapping/>
+  </p:clrMapOvr>
+</p:sld>
+</file>
+
+<file path=ppt/slides/slide24.xml><?xml version="1.0" encoding="utf-8"?>
+<p:sld xmlns:a="http://schemas.openxmlformats.org/drawingml/2006/main" xmlns:r="http://schemas.openxmlformats.org/officeDocument/2006/relationships" xmlns:p="http://schemas.openxmlformats.org/presentationml/2006/main">
+  <p:cSld>
+    <p:spTree>
+      <p:nvGrpSpPr>
+        <p:cNvPr id="1" name="">
+          <a:extLst>
+            <a:ext uri="{FF2B5EF4-FFF2-40B4-BE49-F238E27FC236}">
+              <a16:creationId xmlns:a16="http://schemas.microsoft.com/office/drawing/2014/main" id="{75363010-CED7-4F51-C583-4CE57DFDC27C}"/>
+            </a:ext>
+          </a:extLst>
+        </p:cNvPr>
+        <p:cNvGrpSpPr/>
+        <p:nvPr/>
+      </p:nvGrpSpPr>
+      <p:grpSpPr>
+        <a:xfrm>
+          <a:off x="0" y="0"/>
+          <a:ext cx="0" cy="0"/>
+          <a:chOff x="0" y="0"/>
+          <a:chExt cx="0" cy="0"/>
+        </a:xfrm>
+      </p:grpSpPr>
+      <p:cxnSp>
+        <p:nvCxnSpPr>
+          <p:cNvPr id="6" name="Conector reto 5">
+            <a:extLst>
+              <a:ext uri="{FF2B5EF4-FFF2-40B4-BE49-F238E27FC236}">
+                <a16:creationId xmlns:a16="http://schemas.microsoft.com/office/drawing/2014/main" id="{62B55BD1-485B-E5AC-BC2C-F7B1B2E4016D}"/>
+              </a:ext>
+            </a:extLst>
+          </p:cNvPr>
+          <p:cNvCxnSpPr>
+            <a:cxnSpLocks/>
+          </p:cNvCxnSpPr>
+          <p:nvPr/>
+        </p:nvCxnSpPr>
+        <p:spPr>
+          <a:xfrm>
+            <a:off x="1223682" y="1342275"/>
+            <a:ext cx="9129686" cy="0"/>
+          </a:xfrm>
+          <a:prstGeom prst="line">
+            <a:avLst/>
+          </a:prstGeom>
+          <a:ln/>
+        </p:spPr>
+        <p:style>
+          <a:lnRef idx="3">
+            <a:schemeClr val="accent3"/>
+          </a:lnRef>
+          <a:fillRef idx="0">
+            <a:schemeClr val="accent3"/>
+          </a:fillRef>
+          <a:effectRef idx="2">
+            <a:schemeClr val="accent3"/>
+          </a:effectRef>
+          <a:fontRef idx="minor">
+            <a:schemeClr val="tx1"/>
+          </a:fontRef>
+        </p:style>
+      </p:cxnSp>
+      <p:sp>
+        <p:nvSpPr>
+          <p:cNvPr id="12" name="CaixaDeTexto 11">
+            <a:extLst>
+              <a:ext uri="{FF2B5EF4-FFF2-40B4-BE49-F238E27FC236}">
+                <a16:creationId xmlns:a16="http://schemas.microsoft.com/office/drawing/2014/main" id="{8596AFB1-8ED6-4AFE-B90E-32145A1CF7B9}"/>
+              </a:ext>
+            </a:extLst>
+          </p:cNvPr>
+          <p:cNvSpPr txBox="1"/>
+          <p:nvPr/>
+        </p:nvSpPr>
+        <p:spPr>
+          <a:xfrm>
+            <a:off x="1223681" y="887884"/>
+            <a:ext cx="8065791" cy="707886"/>
+          </a:xfrm>
+          <a:prstGeom prst="rect">
+            <a:avLst/>
+          </a:prstGeom>
+          <a:noFill/>
+        </p:spPr>
+        <p:txBody>
+          <a:bodyPr wrap="square" rtlCol="0">
+            <a:spAutoFit/>
+          </a:bodyPr>
+          <a:lstStyle/>
+          <a:p>
+            <a:r>
+              <a:rPr lang="pt-BR" sz="2000" b="1" dirty="0">
+                <a:latin typeface="Arial" panose="020B0604020202020204" pitchFamily="34" charset="0"/>
+                <a:cs typeface="Arial" panose="020B0604020202020204" pitchFamily="34" charset="0"/>
+              </a:rPr>
+              <a:t>REFERÊNCIAS</a:t>
+            </a:r>
+          </a:p>
+          <a:p>
+            <a:endParaRPr lang="pt-BR" sz="2000" b="1" dirty="0">
+              <a:latin typeface="Arial" panose="020B0604020202020204" pitchFamily="34" charset="0"/>
+              <a:cs typeface="Arial" panose="020B0604020202020204" pitchFamily="34" charset="0"/>
+            </a:endParaRPr>
+          </a:p>
+        </p:txBody>
+      </p:sp>
+      <p:sp>
+        <p:nvSpPr>
+          <p:cNvPr id="5" name="CaixaDeTexto 4">
+            <a:extLst>
+              <a:ext uri="{FF2B5EF4-FFF2-40B4-BE49-F238E27FC236}">
+                <a16:creationId xmlns:a16="http://schemas.microsoft.com/office/drawing/2014/main" id="{526958D8-33AE-4391-289C-018DF30C2D20}"/>
+              </a:ext>
+            </a:extLst>
+          </p:cNvPr>
+          <p:cNvSpPr txBox="1"/>
+          <p:nvPr/>
+        </p:nvSpPr>
+        <p:spPr>
+          <a:xfrm>
+            <a:off x="11602065" y="6488668"/>
+            <a:ext cx="452283" cy="369332"/>
+          </a:xfrm>
+          <a:prstGeom prst="rect">
+            <a:avLst/>
+          </a:prstGeom>
+          <a:noFill/>
+        </p:spPr>
+        <p:txBody>
+          <a:bodyPr wrap="square">
+            <a:spAutoFit/>
+          </a:bodyPr>
+          <a:lstStyle/>
+          <a:p>
+            <a:r>
+              <a:rPr lang="pt-BR" sz="1800" b="1" dirty="0">
+                <a:solidFill>
+                  <a:schemeClr val="bg1"/>
+                </a:solidFill>
+                <a:latin typeface="Arial" panose="020B0604020202020204" pitchFamily="34" charset="0"/>
+                <a:cs typeface="Arial" panose="020B0604020202020204" pitchFamily="34" charset="0"/>
+              </a:rPr>
+              <a:t>6</a:t>
+            </a:r>
+            <a:endParaRPr lang="pt-BR" dirty="0">
+              <a:solidFill>
+                <a:schemeClr val="bg1"/>
+              </a:solidFill>
+            </a:endParaRPr>
+          </a:p>
+        </p:txBody>
+      </p:sp>
+      <p:sp>
+        <p:nvSpPr>
+          <p:cNvPr id="2" name="Título 1">
+            <a:extLst>
+              <a:ext uri="{FF2B5EF4-FFF2-40B4-BE49-F238E27FC236}">
+                <a16:creationId xmlns:a16="http://schemas.microsoft.com/office/drawing/2014/main" id="{5496B41D-4DC0-1668-3102-606087DDEAF7}"/>
+              </a:ext>
+            </a:extLst>
+          </p:cNvPr>
+          <p:cNvSpPr txBox="1">
+            <a:spLocks/>
+          </p:cNvSpPr>
+          <p:nvPr/>
+        </p:nvSpPr>
+        <p:spPr>
+          <a:xfrm>
+            <a:off x="-1" y="6457890"/>
+            <a:ext cx="12192001" cy="400110"/>
+          </a:xfrm>
+          <a:prstGeom prst="rect">
+            <a:avLst/>
+          </a:prstGeom>
+        </p:spPr>
+        <p:style>
+          <a:lnRef idx="0">
+            <a:schemeClr val="accent1"/>
+          </a:lnRef>
+          <a:fillRef idx="3">
+            <a:schemeClr val="accent1"/>
+          </a:fillRef>
+          <a:effectRef idx="3">
+            <a:schemeClr val="accent1"/>
+          </a:effectRef>
+          <a:fontRef idx="minor">
+            <a:schemeClr val="lt1"/>
+          </a:fontRef>
+        </p:style>
+        <p:txBody>
+          <a:bodyPr vert="horz" lIns="91440" tIns="45720" rIns="91440" bIns="45720" rtlCol="0" anchor="ctr">
+            <a:normAutofit/>
+          </a:bodyPr>
+          <a:lstStyle>
+            <a:lvl1pPr algn="ctr" defTabSz="914400" rtl="0" eaLnBrk="1" latinLnBrk="0" hangingPunct="1">
+              <a:lnSpc>
+                <a:spcPct val="90000"/>
+              </a:lnSpc>
+              <a:spcBef>
+                <a:spcPct val="0"/>
+              </a:spcBef>
+              <a:buNone/>
+              <a:defRPr sz="6000" kern="1200">
+                <a:solidFill>
+                  <a:schemeClr val="tx1"/>
+                </a:solidFill>
+                <a:latin typeface="+mj-lt"/>
+                <a:ea typeface="+mj-ea"/>
+                <a:cs typeface="+mj-cs"/>
+              </a:defRPr>
+            </a:lvl1pPr>
+          </a:lstStyle>
+          <a:p>
+            <a:r>
+              <a:rPr lang="pt-BR" sz="2000" b="1" dirty="0">
+                <a:solidFill>
+                  <a:schemeClr val="bg1"/>
+                </a:solidFill>
+                <a:latin typeface="Arial" panose="020B0604020202020204" pitchFamily="34" charset="0"/>
+                <a:cs typeface="Arial" panose="020B0604020202020204" pitchFamily="34" charset="0"/>
+              </a:rPr>
+              <a:t>UNIVERSIDADE FEDERAL DE CAMPINA GRANDE (UFCG)</a:t>
+            </a:r>
+          </a:p>
+        </p:txBody>
+      </p:sp>
+      <p:pic>
+        <p:nvPicPr>
+          <p:cNvPr id="3" name="Picture 2" descr="Logomarcas">
+            <a:extLst>
+              <a:ext uri="{FF2B5EF4-FFF2-40B4-BE49-F238E27FC236}">
+                <a16:creationId xmlns:a16="http://schemas.microsoft.com/office/drawing/2014/main" id="{1B3CA2A4-0073-1125-0ABE-D7079E5B965B}"/>
+              </a:ext>
+            </a:extLst>
+          </p:cNvPr>
+          <p:cNvPicPr>
+            <a:picLocks noChangeAspect="1" noChangeArrowheads="1"/>
+          </p:cNvPicPr>
+          <p:nvPr/>
+        </p:nvPicPr>
+        <p:blipFill>
+          <a:blip r:embed="rId2">
+            <a:extLst>
+              <a:ext uri="{28A0092B-C50C-407E-A947-70E740481C1C}">
+                <a14:useLocalDpi xmlns:a14="http://schemas.microsoft.com/office/drawing/2010/main" val="0"/>
+              </a:ext>
+            </a:extLst>
+          </a:blip>
+          <a:srcRect/>
+          <a:stretch>
+            <a:fillRect/>
+          </a:stretch>
+        </p:blipFill>
+        <p:spPr bwMode="auto">
+          <a:xfrm>
+            <a:off x="10663716" y="269656"/>
+            <a:ext cx="1210588" cy="1236455"/>
+          </a:xfrm>
+          <a:prstGeom prst="rect">
+            <a:avLst/>
+          </a:prstGeom>
+          <a:noFill/>
+          <a:extLst>
+            <a:ext uri="{909E8E84-426E-40DD-AFC4-6F175D3DCCD1}">
+              <a14:hiddenFill xmlns:a14="http://schemas.microsoft.com/office/drawing/2010/main">
+                <a:solidFill>
+                  <a:srgbClr val="FFFFFF"/>
+                </a:solidFill>
+              </a14:hiddenFill>
+            </a:ext>
+          </a:extLst>
+        </p:spPr>
+      </p:pic>
+      <p:sp>
+        <p:nvSpPr>
+          <p:cNvPr id="4" name="Rectangle 1">
+            <a:extLst>
+              <a:ext uri="{FF2B5EF4-FFF2-40B4-BE49-F238E27FC236}">
+                <a16:creationId xmlns:a16="http://schemas.microsoft.com/office/drawing/2014/main" id="{BAF476CD-2D37-141B-53C7-60DB2186AA6A}"/>
+              </a:ext>
+            </a:extLst>
+          </p:cNvPr>
+          <p:cNvSpPr>
+            <a:spLocks noChangeArrowheads="1"/>
+          </p:cNvSpPr>
+          <p:nvPr/>
+        </p:nvSpPr>
+        <p:spPr bwMode="auto">
+          <a:xfrm>
+            <a:off x="1322094" y="1960502"/>
+            <a:ext cx="9547809" cy="3666645"/>
+          </a:xfrm>
+          <a:prstGeom prst="rect">
+            <a:avLst/>
+          </a:prstGeom>
+          <a:noFill/>
+          <a:ln>
+            <a:noFill/>
+          </a:ln>
+          <a:effectLst/>
+          <a:extLst>
+            <a:ext uri="{909E8E84-426E-40DD-AFC4-6F175D3DCCD1}">
+              <a14:hiddenFill xmlns:a14="http://schemas.microsoft.com/office/drawing/2010/main">
+                <a:solidFill>
+                  <a:schemeClr val="accent1"/>
+                </a:solidFill>
+              </a14:hiddenFill>
+            </a:ext>
+            <a:ext uri="{91240B29-F687-4F45-9708-019B960494DF}">
+              <a14:hiddenLine xmlns:a14="http://schemas.microsoft.com/office/drawing/2010/main" w="9525">
+                <a:solidFill>
+                  <a:schemeClr val="tx1"/>
+                </a:solidFill>
+                <a:miter lim="800000"/>
+                <a:headEnd/>
+                <a:tailEnd/>
+              </a14:hiddenLine>
+            </a:ext>
+            <a:ext uri="{AF507438-7753-43E0-B8FC-AC1667EBCBE1}">
+              <a14:hiddenEffects xmlns:a14="http://schemas.microsoft.com/office/drawing/2010/main">
+                <a:effectLst>
+                  <a:outerShdw dist="35921" dir="2700000" algn="ctr" rotWithShape="0">
+                    <a:schemeClr val="bg2"/>
+                  </a:outerShdw>
+                </a:effectLst>
+              </a14:hiddenEffects>
+            </a:ext>
+          </a:extLst>
+        </p:spPr>
+        <p:txBody>
+          <a:bodyPr vert="horz" wrap="square" lIns="91440" tIns="45720" rIns="91440" bIns="45720" numCol="1" anchor="ctr" anchorCtr="0" compatLnSpc="1">
+            <a:prstTxWarp prst="textNoShape">
+              <a:avLst/>
+            </a:prstTxWarp>
+            <a:spAutoFit/>
+          </a:bodyPr>
+          <a:lstStyle/>
+          <a:p>
+            <a:pPr marL="228600" indent="-228600" algn="just">
+              <a:lnSpc>
+                <a:spcPct val="150000"/>
+              </a:lnSpc>
+              <a:buFont typeface="Arial" panose="020B0604020202020204" pitchFamily="34" charset="0"/>
+              <a:buChar char="•"/>
+            </a:pPr>
+            <a:r>
+              <a:rPr lang="pt-BR" sz="1200" dirty="0"/>
+              <a:t>GERON, A. </a:t>
+            </a:r>
+            <a:r>
+              <a:rPr lang="pt-BR" sz="1200" b="1" dirty="0"/>
+              <a:t>Hands-On Machine Learning </a:t>
+            </a:r>
+            <a:r>
+              <a:rPr lang="pt-BR" sz="1200" b="1" dirty="0" err="1"/>
+              <a:t>with</a:t>
+            </a:r>
+            <a:r>
+              <a:rPr lang="pt-BR" sz="1200" b="1" dirty="0"/>
+              <a:t> </a:t>
+            </a:r>
+            <a:r>
+              <a:rPr lang="pt-BR" sz="1200" b="1" dirty="0" err="1"/>
+              <a:t>Scikit-Learn</a:t>
+            </a:r>
+            <a:r>
+              <a:rPr lang="pt-BR" sz="1200" b="1" dirty="0"/>
+              <a:t>, </a:t>
+            </a:r>
+            <a:r>
+              <a:rPr lang="pt-BR" sz="1200" b="1" dirty="0" err="1"/>
+              <a:t>Keras</a:t>
+            </a:r>
+            <a:r>
+              <a:rPr lang="pt-BR" sz="1200" b="1" dirty="0"/>
+              <a:t>, </a:t>
+            </a:r>
+            <a:r>
+              <a:rPr lang="pt-BR" sz="1200" b="1" dirty="0" err="1"/>
+              <a:t>and</a:t>
+            </a:r>
+            <a:r>
+              <a:rPr lang="pt-BR" sz="1200" b="1" dirty="0"/>
+              <a:t> </a:t>
+            </a:r>
+            <a:r>
+              <a:rPr lang="pt-BR" sz="1200" b="1" dirty="0" err="1"/>
+              <a:t>TensorFlow</a:t>
+            </a:r>
+            <a:r>
+              <a:rPr lang="pt-BR" sz="1200" dirty="0"/>
+              <a:t>: </a:t>
+            </a:r>
+            <a:r>
+              <a:rPr lang="pt-BR" sz="1200" dirty="0" err="1"/>
+              <a:t>Concepts</a:t>
+            </a:r>
+            <a:r>
+              <a:rPr lang="pt-BR" sz="1200" dirty="0"/>
+              <a:t>, Tools, </a:t>
+            </a:r>
+            <a:r>
+              <a:rPr lang="pt-BR" sz="1200" dirty="0" err="1"/>
+              <a:t>and</a:t>
+            </a:r>
+            <a:r>
+              <a:rPr lang="pt-BR" sz="1200" dirty="0"/>
+              <a:t> </a:t>
+            </a:r>
+            <a:r>
+              <a:rPr lang="pt-BR" sz="1200" dirty="0" err="1"/>
+              <a:t>Techniques</a:t>
+            </a:r>
+            <a:r>
+              <a:rPr lang="pt-BR" sz="1200" dirty="0"/>
+              <a:t> </a:t>
+            </a:r>
+            <a:r>
+              <a:rPr lang="pt-BR" sz="1200" dirty="0" err="1"/>
+              <a:t>to</a:t>
+            </a:r>
+            <a:r>
+              <a:rPr lang="pt-BR" sz="1200" dirty="0"/>
+              <a:t> Build </a:t>
+            </a:r>
+            <a:r>
+              <a:rPr lang="pt-BR" sz="1200" dirty="0" err="1"/>
+              <a:t>Intelligent</a:t>
+            </a:r>
+            <a:r>
+              <a:rPr lang="pt-BR" sz="1200" dirty="0"/>
+              <a:t> Systems. 2. ed. [S. l.]: O’Reilly Media, Inc., 2019.</a:t>
+            </a:r>
+          </a:p>
+          <a:p>
+            <a:pPr marL="228600" indent="-228600" algn="just">
+              <a:lnSpc>
+                <a:spcPct val="150000"/>
+              </a:lnSpc>
+              <a:buFont typeface="Arial" panose="020B0604020202020204" pitchFamily="34" charset="0"/>
+              <a:buChar char="•"/>
+            </a:pPr>
+            <a:r>
+              <a:rPr lang="pt-BR" sz="1200" dirty="0"/>
+              <a:t>GERTLER, J. </a:t>
+            </a:r>
+            <a:r>
+              <a:rPr lang="pt-BR" sz="1200" b="1" dirty="0" err="1"/>
+              <a:t>Fault</a:t>
+            </a:r>
+            <a:r>
+              <a:rPr lang="pt-BR" sz="1200" b="1" dirty="0"/>
+              <a:t> </a:t>
+            </a:r>
+            <a:r>
+              <a:rPr lang="pt-BR" sz="1200" b="1" dirty="0" err="1"/>
+              <a:t>detection</a:t>
+            </a:r>
+            <a:r>
+              <a:rPr lang="pt-BR" sz="1200" b="1" dirty="0"/>
+              <a:t> </a:t>
+            </a:r>
+            <a:r>
+              <a:rPr lang="pt-BR" sz="1200" b="1" dirty="0" err="1"/>
+              <a:t>and</a:t>
+            </a:r>
+            <a:r>
+              <a:rPr lang="pt-BR" sz="1200" b="1" dirty="0"/>
+              <a:t> </a:t>
+            </a:r>
+            <a:r>
+              <a:rPr lang="pt-BR" sz="1200" b="1" dirty="0" err="1"/>
+              <a:t>diagnosis</a:t>
+            </a:r>
+            <a:r>
+              <a:rPr lang="pt-BR" sz="1200" b="1" dirty="0"/>
+              <a:t> in </a:t>
+            </a:r>
+            <a:r>
+              <a:rPr lang="pt-BR" sz="1200" b="1" dirty="0" err="1"/>
+              <a:t>engineering</a:t>
+            </a:r>
+            <a:r>
+              <a:rPr lang="pt-BR" sz="1200" b="1" dirty="0"/>
+              <a:t> systems</a:t>
+            </a:r>
+            <a:r>
+              <a:rPr lang="pt-BR" sz="1200" dirty="0"/>
+              <a:t>. New York: Marcel Dekker, 1998.</a:t>
+            </a:r>
+          </a:p>
+          <a:p>
+            <a:pPr marL="228600" indent="-228600" algn="just">
+              <a:lnSpc>
+                <a:spcPct val="150000"/>
+              </a:lnSpc>
+              <a:buFont typeface="Arial" panose="020B0604020202020204" pitchFamily="34" charset="0"/>
+              <a:buChar char="•"/>
+            </a:pPr>
+            <a:r>
+              <a:rPr lang="pt-BR" sz="1200" dirty="0"/>
+              <a:t>ISERMANN, R. </a:t>
+            </a:r>
+            <a:r>
+              <a:rPr lang="pt-BR" sz="1200" b="1" dirty="0" err="1"/>
+              <a:t>Fault-diagnosis</a:t>
+            </a:r>
+            <a:r>
+              <a:rPr lang="pt-BR" sz="1200" b="1" dirty="0"/>
+              <a:t> </a:t>
+            </a:r>
+            <a:r>
+              <a:rPr lang="pt-BR" sz="1200" b="1" dirty="0" err="1"/>
+              <a:t>applications</a:t>
+            </a:r>
+            <a:r>
+              <a:rPr lang="pt-BR" sz="1200" dirty="0"/>
+              <a:t>: Model-</a:t>
+            </a:r>
+            <a:r>
+              <a:rPr lang="pt-BR" sz="1200" dirty="0" err="1"/>
+              <a:t>aided</a:t>
+            </a:r>
+            <a:r>
+              <a:rPr lang="pt-BR" sz="1200" dirty="0"/>
+              <a:t> </a:t>
+            </a:r>
+            <a:r>
+              <a:rPr lang="pt-BR" sz="1200" dirty="0" err="1"/>
+              <a:t>diagnosis</a:t>
+            </a:r>
+            <a:r>
+              <a:rPr lang="pt-BR" sz="1200" dirty="0"/>
+              <a:t> </a:t>
+            </a:r>
+            <a:r>
+              <a:rPr lang="pt-BR" sz="1200" dirty="0" err="1"/>
+              <a:t>and</a:t>
+            </a:r>
+            <a:r>
+              <a:rPr lang="pt-BR" sz="1200" dirty="0"/>
+              <a:t> </a:t>
+            </a:r>
+            <a:r>
+              <a:rPr lang="pt-BR" sz="1200" dirty="0" err="1"/>
+              <a:t>fault-tolerant</a:t>
+            </a:r>
+            <a:r>
+              <a:rPr lang="pt-BR" sz="1200" dirty="0"/>
+              <a:t> </a:t>
+            </a:r>
+            <a:r>
+              <a:rPr lang="pt-BR" sz="1200" dirty="0" err="1"/>
+              <a:t>control</a:t>
+            </a:r>
+            <a:r>
+              <a:rPr lang="pt-BR" sz="1200" dirty="0"/>
+              <a:t>. Berlin, Heidelberg: Springer-</a:t>
+            </a:r>
+            <a:r>
+              <a:rPr lang="pt-BR" sz="1200" dirty="0" err="1"/>
+              <a:t>Verlag</a:t>
+            </a:r>
+            <a:r>
+              <a:rPr lang="pt-BR" sz="1200" dirty="0"/>
+              <a:t>, 2011.</a:t>
+            </a:r>
+          </a:p>
+          <a:p>
+            <a:pPr marL="228600" indent="-228600" algn="just">
+              <a:lnSpc>
+                <a:spcPct val="150000"/>
+              </a:lnSpc>
+              <a:buFont typeface="Wingdings" panose="05000000000000000000" pitchFamily="2" charset="2"/>
+              <a:buChar char="Ø"/>
+            </a:pPr>
+            <a:r>
+              <a:rPr lang="pt-BR" sz="1200" dirty="0">
+                <a:highlight>
+                  <a:srgbClr val="FFFF00"/>
+                </a:highlight>
+              </a:rPr>
               <a:t>SILVA, S. J. A. </a:t>
             </a:r>
             <a:r>
-              <a:rPr lang="pt-BR" sz="1200" b="1" dirty="0"/>
+              <a:rPr lang="pt-BR" sz="1200" b="1" dirty="0">
+                <a:highlight>
+                  <a:srgbClr val="FFFF00"/>
+                </a:highlight>
+              </a:rPr>
               <a:t>Atividade 3 - Identificação de Falhas (Sistemas Inteligentes 2026)</a:t>
             </a:r>
             <a:r>
-              <a:rPr lang="pt-BR" sz="1200" dirty="0"/>
+              <a:rPr lang="pt-BR" sz="1200" dirty="0">
+                <a:highlight>
+                  <a:srgbClr val="FFFF00"/>
+                </a:highlight>
+              </a:rPr>
               <a:t>. Repositório GitHub, 2026. Disponível em: </a:t>
             </a:r>
             <a:r>
               <a:rPr lang="pt-BR" sz="1200" dirty="0">
+                <a:highlight>
+                  <a:srgbClr val="FFFF00"/>
+                </a:highlight>
                 <a:hlinkClick r:id="rId3"/>
               </a:rPr>
               <a:t>https://github.com/</a:t>
             </a:r>
             <a:r>
               <a:rPr lang="pt-BR" sz="1200" dirty="0" err="1">
+                <a:highlight>
+                  <a:srgbClr val="FFFF00"/>
+                </a:highlight>
                 <a:hlinkClick r:id="rId3"/>
               </a:rPr>
               <a:t>SauloJose</a:t>
             </a:r>
             <a:r>
               <a:rPr lang="pt-BR" sz="1200" dirty="0">
+                <a:highlight>
+                  <a:srgbClr val="FFFF00"/>
+                </a:highlight>
                 <a:hlinkClick r:id="rId3"/>
               </a:rPr>
               <a:t>/SistemasInteligentes2026/</a:t>
             </a:r>
             <a:r>
               <a:rPr lang="pt-BR" sz="1200" dirty="0" err="1">
+                <a:highlight>
+                  <a:srgbClr val="FFFF00"/>
+                </a:highlight>
                 <a:hlinkClick r:id="rId3"/>
               </a:rPr>
               <a:t>tree</a:t>
             </a:r>
             <a:r>
               <a:rPr lang="pt-BR" sz="1200" dirty="0">
+                <a:highlight>
+                  <a:srgbClr val="FFFF00"/>
+                </a:highlight>
                 <a:hlinkClick r:id="rId3"/>
               </a:rPr>
               <a:t>/</a:t>
             </a:r>
             <a:r>
               <a:rPr lang="pt-BR" sz="1200" dirty="0" err="1">
+                <a:highlight>
+                  <a:srgbClr val="FFFF00"/>
+                </a:highlight>
                 <a:hlinkClick r:id="rId3"/>
               </a:rPr>
               <a:t>main</a:t>
             </a:r>
             <a:r>
               <a:rPr lang="pt-BR" sz="1200" dirty="0">
+                <a:highlight>
+                  <a:srgbClr val="FFFF00"/>
+                </a:highlight>
                 <a:hlinkClick r:id="rId3"/>
               </a:rPr>
               <a:t>/Atividade%203%20-%20Identifica%C3%A7%C3%A3o%20de%20Falhas</a:t>
             </a:r>
             <a:r>
-              <a:rPr lang="pt-BR" sz="1200" dirty="0"/>
+              <a:rPr lang="pt-BR" sz="1200" dirty="0">
+                <a:highlight>
+                  <a:srgbClr val="FFFF00"/>
+                </a:highlight>
+              </a:rPr>
               <a:t>. Acesso em: 18 maio 2026.</a:t>
             </a:r>
           </a:p>
@@ -14434,7 +15067,7 @@
 </p:sld>
 </file>
 
-<file path=ppt/slides/slide24.xml><?xml version="1.0" encoding="utf-8"?>
+<file path=ppt/slides/slide25.xml><?xml version="1.0" encoding="utf-8"?>
 <p:sld xmlns:a="http://schemas.openxmlformats.org/drawingml/2006/main" xmlns:r="http://schemas.openxmlformats.org/officeDocument/2006/relationships" xmlns:p="http://schemas.openxmlformats.org/presentationml/2006/main">
   <p:cSld>
     <p:spTree>

</xml_diff>